<commit_message>
Apply scout logo branding (green/red palette, logo on every slide) to both decks
Co-Authored-By: Claude Opus 5.5 <noreply@anthropic.com>
Claude-Session: https://claude.ai/code/session_01UrQvtGwHE3JAQFqPrbcntd
</commit_message>
<xml_diff>
--- a/docs/scout-training/المحاضرة_الثانية_خصائص_الراشدين.pptx
+++ b/docs/scout-training/المحاضرة_الثانية_خصائص_الراشدين.pptx
@@ -114,30 +114,30 @@
   <p:extLst>
     <p:ext uri="{521415D9-36F7-43E2-AB2F-B90AF26B5E84}">
       <p14:sectionLst xmlns:p14="http://schemas.microsoft.com/office/powerpoint/2010/main">
-        <p14:section name="الافتتاح" id="{0ea17a9a-ddc4-3cfb-4edc-0f7b52187094}">
+        <p14:section name="الافتتاح" id="{42a3b00c-9783-e7c5-245c-a50c14b61ab7}">
           <p14:sldIdLst>
             <p14:sldId id="256"/>
           </p14:sldIdLst>
         </p14:section>
-        <p14:section name="الخصائص" id="{497f6408-1b09-436a-80e6-cc6777a8ae27}">
+        <p14:section name="الخصائص" id="{85d126a2-b843-1ae9-4566-ab3f7ef0591f}">
           <p14:sldIdLst>
             <p14:sldId id="257"/>
             <p14:sldId id="258"/>
           </p14:sldIdLst>
         </p14:section>
-        <p14:section name="الاحتياجات" id="{b8b288d7-5f22-6730-dcdd-44ce252520c6}">
+        <p14:section name="الاحتياجات" id="{a8f13191-d63d-5dbf-68e2-461d1c6054fc}">
           <p14:sldIdLst>
             <p14:sldId id="259"/>
           </p14:sldIdLst>
         </p14:section>
-        <p14:section name="طرق التدريب" id="{6db0e4a7-8177-5945-c35d-6d911262bca5}">
+        <p14:section name="طرق التدريب" id="{e063c018-9bb7-aef1-c71c-85c1eba843dc}">
           <p14:sldIdLst>
             <p14:sldId id="260"/>
             <p14:sldId id="261"/>
             <p14:sldId id="262"/>
           </p14:sldIdLst>
         </p14:section>
-        <p14:section name="الختام" id="{fcb876ad-0b2c-e017-4180-a40b9f06bb1e}">
+        <p14:section name="الختام" id="{c05d76eb-b7ea-6def-7b63-6159aacaf7c7}">
           <p14:sldIdLst>
             <p14:sldId id="263"/>
           </p14:sldIdLst>
@@ -1258,12 +1258,36 @@
           <a:chExt cx="0" cy="0"/>
         </a:xfrm>
       </p:grpSpPr>
-      <p:sp>
-        <p:nvSpPr>
-          <p:cNvPr id="2" name="Text 0"/>
+      <p:pic>
+        <p:nvPicPr>
+          <p:cNvPr id="2" name="Image 0" descr="شعار الكشافة الإسلامية الجزائرية">    </p:cNvPr>
+          <p:cNvPicPr>
+            <a:picLocks noChangeAspect="1"/>
+          </p:cNvPicPr>
+          <p:nvPr/>
+        </p:nvPicPr>
+        <p:blipFill>
+          <a:blip r:embed="rId1"/>
+          <a:stretch>
+            <a:fillRect/>
+          </a:stretch>
+        </p:blipFill>
+        <p:spPr>
+          <a:xfrm>
+            <a:off x="548640" y="457200"/>
+            <a:ext cx="1554480" cy="1554480"/>
+          </a:xfrm>
+          <a:prstGeom prst="rect">
+            <a:avLst/>
+          </a:prstGeom>
+        </p:spPr>
+      </p:pic>
+      <p:sp>
+        <p:nvSpPr>
+          <p:cNvPr id="3" name="Text 0"/>
           <p:cNvSpPr/>
           <p:nvPr>
-            <p:ph idx="100" type="title" hasCustomPrompt="1"/>
+            <p:ph idx="101" type="title" hasCustomPrompt="1"/>
           </p:nvPr>
         </p:nvSpPr>
         <p:spPr>
@@ -1299,10 +1323,10 @@
       </p:sp>
       <p:sp>
         <p:nvSpPr>
-          <p:cNvPr id="3" name="Text 0"/>
+          <p:cNvPr id="4" name="Text 0"/>
           <p:cNvSpPr/>
           <p:nvPr>
-            <p:ph idx="101" type="body" hasCustomPrompt="1"/>
+            <p:ph idx="102" type="body" hasCustomPrompt="1"/>
           </p:nvPr>
         </p:nvSpPr>
         <p:spPr>
@@ -1323,7 +1347,7 @@
               <a:buNone/>
               <a:defRPr lang="ar-SA" altLang="en-US" sz="2200" dirty="0">
                 <a:solidFill>
-                  <a:schemeClr val="accent2"/>
+                  <a:schemeClr val="bg2"/>
                 </a:solidFill>
               </a:defRPr>
             </a:lvl1pPr>
@@ -1368,12 +1392,36 @@
           <a:chExt cx="0" cy="0"/>
         </a:xfrm>
       </p:grpSpPr>
-      <p:sp>
-        <p:nvSpPr>
-          <p:cNvPr id="2" name="Text 0"/>
+      <p:pic>
+        <p:nvPicPr>
+          <p:cNvPr id="2" name="Image 0" descr="شعار الكشافة الإسلامية الجزائرية">    </p:cNvPr>
+          <p:cNvPicPr>
+            <a:picLocks noChangeAspect="1"/>
+          </p:cNvPicPr>
+          <p:nvPr/>
+        </p:nvPicPr>
+        <p:blipFill>
+          <a:blip r:embed="rId1"/>
+          <a:stretch>
+            <a:fillRect/>
+          </a:stretch>
+        </p:blipFill>
+        <p:spPr>
+          <a:xfrm>
+            <a:off x="548640" y="457200"/>
+            <a:ext cx="1097280" cy="1097280"/>
+          </a:xfrm>
+          <a:prstGeom prst="rect">
+            <a:avLst/>
+          </a:prstGeom>
+        </p:spPr>
+      </p:pic>
+      <p:sp>
+        <p:nvSpPr>
+          <p:cNvPr id="3" name="Text 0"/>
           <p:cNvSpPr/>
           <p:nvPr>
-            <p:ph idx="100" type="title" hasCustomPrompt="1"/>
+            <p:ph idx="101" type="title" hasCustomPrompt="1"/>
           </p:nvPr>
         </p:nvSpPr>
         <p:spPr>
@@ -1409,10 +1457,10 @@
       </p:sp>
       <p:sp>
         <p:nvSpPr>
-          <p:cNvPr id="3" name="Text 0"/>
+          <p:cNvPr id="4" name="Text 0"/>
           <p:cNvSpPr/>
           <p:nvPr>
-            <p:ph idx="101" type="body" hasCustomPrompt="1"/>
+            <p:ph idx="102" type="body" hasCustomPrompt="1"/>
           </p:nvPr>
         </p:nvSpPr>
         <p:spPr>
@@ -1433,7 +1481,7 @@
               <a:buNone/>
               <a:defRPr lang="ar-SA" altLang="en-US" sz="2000" dirty="0">
                 <a:solidFill>
-                  <a:schemeClr val="accent2"/>
+                  <a:schemeClr val="bg2"/>
                 </a:solidFill>
               </a:defRPr>
             </a:lvl1pPr>
@@ -1523,18 +1571,42 @@
           <a:chExt cx="0" cy="0"/>
         </a:xfrm>
       </p:grpSpPr>
-      <p:sp>
-        <p:nvSpPr>
-          <p:cNvPr id="2" name="Text 0"/>
+      <p:pic>
+        <p:nvPicPr>
+          <p:cNvPr id="2" name="Image 0" descr="شعار الكشافة الإسلامية الجزائرية">    </p:cNvPr>
+          <p:cNvPicPr>
+            <a:picLocks noChangeAspect="1"/>
+          </p:cNvPicPr>
+          <p:nvPr/>
+        </p:nvPicPr>
+        <p:blipFill>
+          <a:blip r:embed="rId1"/>
+          <a:stretch>
+            <a:fillRect/>
+          </a:stretch>
+        </p:blipFill>
+        <p:spPr>
+          <a:xfrm>
+            <a:off x="548640" y="365760"/>
+            <a:ext cx="822960" cy="822960"/>
+          </a:xfrm>
+          <a:prstGeom prst="rect">
+            <a:avLst/>
+          </a:prstGeom>
+        </p:spPr>
+      </p:pic>
+      <p:sp>
+        <p:nvSpPr>
+          <p:cNvPr id="3" name="Text 0"/>
           <p:cNvSpPr/>
           <p:nvPr>
-            <p:ph idx="100" type="title" hasCustomPrompt="1"/>
+            <p:ph idx="101" type="title" hasCustomPrompt="1"/>
           </p:nvPr>
         </p:nvSpPr>
         <p:spPr>
           <a:xfrm>
-            <a:off x="548640" y="365760"/>
-            <a:ext cx="11094415" cy="822960"/>
+            <a:off x="1645920" y="365760"/>
+            <a:ext cx="9997135" cy="822960"/>
           </a:xfrm>
           <a:prstGeom prst="rect">
             <a:avLst/>
@@ -1564,7 +1636,7 @@
       </p:sp>
       <p:sp>
         <p:nvSpPr>
-          <p:cNvPr id="3" name="Text 0"/>
+          <p:cNvPr id="4" name="Text 0"/>
           <p:cNvSpPr/>
           <p:nvPr/>
         </p:nvSpPr>
@@ -1592,7 +1664,7 @@
                   <a:srgbClr val="5E6E66"/>
                 </a:solidFill>
               </a:rPr>
-              <a:t>دورة مساعد قائد تدريب  |  المحاضرة الثانية: خصائص الراشدين</a:t>
+              <a:t>الكشافة الإسلامية الجزائرية  |  دورة مساعد قائد تدريب  |  المحاضرة الثانية: خصائص الراشدين</a:t>
             </a:r>
             <a:endParaRPr lang="ar-SA" sz="1000" dirty="0"/>
           </a:p>
@@ -1998,7 +2070,7 @@
           <p:cNvPr id="2" name="Text 0"/>
           <p:cNvSpPr/>
           <p:nvPr>
-            <p:ph idx="100" type="title" hasCustomPrompt="1"/>
+            <p:ph idx="101" type="title" hasCustomPrompt="1"/>
           </p:nvPr>
         </p:nvSpPr>
         <p:spPr>
@@ -2036,7 +2108,7 @@
           <p:cNvPr id="3" name="Text 0"/>
           <p:cNvSpPr/>
           <p:nvPr>
-            <p:ph idx="101" type="body" hasCustomPrompt="1"/>
+            <p:ph idx="102" type="body" hasCustomPrompt="1"/>
           </p:nvPr>
         </p:nvSpPr>
         <p:spPr>
@@ -2060,7 +2132,7 @@
             <a:r>
               <a:rPr lang="ar-SA" altLang="en-US" sz="2200" dirty="0">
                 <a:solidFill>
-                  <a:schemeClr val="accent2"/>
+                  <a:schemeClr val="bg2"/>
                 </a:solidFill>
               </a:rPr>
               <a:t>المحاضرة الثانية  —  دورة مساعد قائد تدريب</a:t>
@@ -2069,33 +2141,9 @@
           </a:p>
         </p:txBody>
       </p:sp>
-      <p:pic>
-        <p:nvPicPr>
-          <p:cNvPr id="4" name="cover-icon" descr="متعلم راشد">    </p:cNvPr>
-          <p:cNvPicPr>
-            <a:picLocks noChangeAspect="1"/>
-          </p:cNvPicPr>
-          <p:nvPr/>
-        </p:nvPicPr>
-        <p:blipFill>
-          <a:blip r:embed="rId1"/>
-          <a:stretch>
-            <a:fillRect/>
-          </a:stretch>
-        </p:blipFill>
-        <p:spPr>
-          <a:xfrm>
-            <a:off x="548640" y="548640"/>
-            <a:ext cx="1188720" cy="1188720"/>
-          </a:xfrm>
-          <a:prstGeom prst="rect">
-            <a:avLst/>
-          </a:prstGeom>
-        </p:spPr>
-      </p:pic>
-      <p:sp>
-        <p:nvSpPr>
-          <p:cNvPr id="5" name="Text 2"/>
+      <p:sp>
+        <p:nvSpPr>
+          <p:cNvPr id="4" name="Text 2"/>
           <p:cNvSpPr txBox="1"/>
           <p:nvPr/>
         </p:nvSpPr>
@@ -2159,13 +2207,13 @@
           <p:cNvPr id="2" name="Text 0"/>
           <p:cNvSpPr/>
           <p:nvPr>
-            <p:ph idx="100" type="title" hasCustomPrompt="1"/>
+            <p:ph idx="101" type="title" hasCustomPrompt="1"/>
           </p:nvPr>
         </p:nvSpPr>
         <p:spPr>
           <a:xfrm>
-            <a:off x="548640" y="365760"/>
-            <a:ext cx="11094415" cy="822960"/>
+            <a:off x="1645920" y="365760"/>
+            <a:ext cx="9997135" cy="822960"/>
           </a:xfrm>
           <a:prstGeom prst="rect">
             <a:avLst/>
@@ -2285,7 +2333,7 @@
             <a:r>
               <a:rPr lang="ar-SA" altLang="en-US" sz="2200" b="1" dirty="0">
                 <a:solidFill>
-                  <a:srgbClr val="D9A425"/>
+                  <a:srgbClr val="D7141A"/>
                 </a:solidFill>
               </a:rPr>
               <a:t>01  </a:t>
@@ -2434,7 +2482,7 @@
             <a:r>
               <a:rPr lang="ar-SA" altLang="en-US" sz="2200" b="1" dirty="0">
                 <a:solidFill>
-                  <a:srgbClr val="D9A425"/>
+                  <a:srgbClr val="D7141A"/>
                 </a:solidFill>
               </a:rPr>
               <a:t>02  </a:t>
@@ -2583,7 +2631,7 @@
             <a:r>
               <a:rPr lang="ar-SA" altLang="en-US" sz="2200" b="1" dirty="0">
                 <a:solidFill>
-                  <a:srgbClr val="D9A425"/>
+                  <a:srgbClr val="D7141A"/>
                 </a:solidFill>
               </a:rPr>
               <a:t>03  </a:t>
@@ -2732,7 +2780,7 @@
             <a:r>
               <a:rPr lang="ar-SA" altLang="en-US" sz="2200" b="1" dirty="0">
                 <a:solidFill>
-                  <a:srgbClr val="D9A425"/>
+                  <a:srgbClr val="D7141A"/>
                 </a:solidFill>
               </a:rPr>
               <a:t>04  </a:t>
@@ -2881,7 +2929,7 @@
             <a:r>
               <a:rPr lang="ar-SA" altLang="en-US" sz="2200" b="1" dirty="0">
                 <a:solidFill>
-                  <a:srgbClr val="D9A425"/>
+                  <a:srgbClr val="D7141A"/>
                 </a:solidFill>
               </a:rPr>
               <a:t>05  </a:t>
@@ -3030,7 +3078,7 @@
             <a:r>
               <a:rPr lang="ar-SA" altLang="en-US" sz="2200" b="1" dirty="0">
                 <a:solidFill>
-                  <a:srgbClr val="D9A425"/>
+                  <a:srgbClr val="D7141A"/>
                 </a:solidFill>
               </a:rPr>
               <a:t>06  </a:t>
@@ -3161,13 +3209,13 @@
           <p:cNvPr id="2" name="Text 0"/>
           <p:cNvSpPr/>
           <p:nvPr>
-            <p:ph idx="100" type="title" hasCustomPrompt="1"/>
+            <p:ph idx="101" type="title" hasCustomPrompt="1"/>
           </p:nvPr>
         </p:nvSpPr>
         <p:spPr>
           <a:xfrm>
-            <a:off x="548640" y="365760"/>
-            <a:ext cx="11094415" cy="822960"/>
+            <a:off x="1645920" y="365760"/>
+            <a:ext cx="9997135" cy="822960"/>
           </a:xfrm>
           <a:prstGeom prst="rect">
             <a:avLst/>
@@ -3287,7 +3335,7 @@
             <a:r>
               <a:rPr lang="ar-SA" altLang="en-US" sz="2200" b="1" dirty="0">
                 <a:solidFill>
-                  <a:schemeClr val="accent2"/>
+                  <a:schemeClr val="bg2"/>
                 </a:solidFill>
               </a:rPr>
               <a:t>التعريف</a:t>
@@ -3728,13 +3776,13 @@
           <p:cNvPr id="2" name="Text 0"/>
           <p:cNvSpPr/>
           <p:nvPr>
-            <p:ph idx="100" type="title" hasCustomPrompt="1"/>
+            <p:ph idx="101" type="title" hasCustomPrompt="1"/>
           </p:nvPr>
         </p:nvSpPr>
         <p:spPr>
           <a:xfrm>
-            <a:off x="548640" y="365760"/>
-            <a:ext cx="11094415" cy="822960"/>
+            <a:off x="1645920" y="365760"/>
+            <a:ext cx="9997135" cy="822960"/>
           </a:xfrm>
           <a:prstGeom prst="rect">
             <a:avLst/>
@@ -3846,7 +3894,7 @@
                       <a:tailEnd type="none" w="med" len="med"/>
                     </a:lnB>
                     <a:solidFill>
-                      <a:srgbClr val="1F4D3A"/>
+                      <a:srgbClr val="00632B"/>
                     </a:solidFill>
                   </a:tcPr>
                 </a:tc>
@@ -3907,7 +3955,7 @@
                       <a:tailEnd type="none" w="med" len="med"/>
                     </a:lnB>
                     <a:solidFill>
-                      <a:srgbClr val="1F4D3A"/>
+                      <a:srgbClr val="00632B"/>
                     </a:solidFill>
                   </a:tcPr>
                 </a:tc>
@@ -3968,7 +4016,7 @@
                       <a:tailEnd type="none" w="med" len="med"/>
                     </a:lnB>
                     <a:solidFill>
-                      <a:srgbClr val="1F4D3A"/>
+                      <a:srgbClr val="00632B"/>
                     </a:solidFill>
                   </a:tcPr>
                 </a:tc>
@@ -4031,7 +4079,7 @@
                       <a:tailEnd type="none" w="med" len="med"/>
                     </a:lnB>
                     <a:solidFill>
-                      <a:srgbClr val="EAF2EC"/>
+                      <a:srgbClr val="EAF5EC"/>
                     </a:solidFill>
                   </a:tcPr>
                 </a:tc>
@@ -4092,7 +4140,7 @@
                       <a:tailEnd type="none" w="med" len="med"/>
                     </a:lnB>
                     <a:solidFill>
-                      <a:srgbClr val="EAF2EC"/>
+                      <a:srgbClr val="EAF5EC"/>
                     </a:solidFill>
                   </a:tcPr>
                 </a:tc>
@@ -4107,7 +4155,7 @@
                       <a:r>
                         <a:rPr lang="ar-SA" altLang="en-US" sz="1500" b="1" dirty="0">
                           <a:solidFill>
-                            <a:srgbClr val="1F4D3A"/>
+                            <a:srgbClr val="00632B"/>
                           </a:solidFill>
                         </a:rPr>
                         <a:t>خبرة تراكمية</a:t>
@@ -4153,7 +4201,7 @@
                       <a:tailEnd type="none" w="med" len="med"/>
                     </a:lnB>
                     <a:solidFill>
-                      <a:srgbClr val="EAF2EC"/>
+                      <a:srgbClr val="EAF5EC"/>
                     </a:solidFill>
                   </a:tcPr>
                 </a:tc>
@@ -4292,7 +4340,7 @@
                       <a:r>
                         <a:rPr lang="ar-SA" altLang="en-US" sz="1500" b="1" dirty="0">
                           <a:solidFill>
-                            <a:srgbClr val="1F4D3A"/>
+                            <a:srgbClr val="00632B"/>
                           </a:solidFill>
                         </a:rPr>
                         <a:t>الاستقلالية</a:t>
@@ -4401,7 +4449,7 @@
                       <a:tailEnd type="none" w="med" len="med"/>
                     </a:lnB>
                     <a:solidFill>
-                      <a:srgbClr val="EAF2EC"/>
+                      <a:srgbClr val="EAF5EC"/>
                     </a:solidFill>
                   </a:tcPr>
                 </a:tc>
@@ -4462,7 +4510,7 @@
                       <a:tailEnd type="none" w="med" len="med"/>
                     </a:lnB>
                     <a:solidFill>
-                      <a:srgbClr val="EAF2EC"/>
+                      <a:srgbClr val="EAF5EC"/>
                     </a:solidFill>
                   </a:tcPr>
                 </a:tc>
@@ -4477,7 +4525,7 @@
                       <a:r>
                         <a:rPr lang="ar-SA" altLang="en-US" sz="1500" b="1" dirty="0">
                           <a:solidFill>
-                            <a:srgbClr val="1F4D3A"/>
+                            <a:srgbClr val="00632B"/>
                           </a:solidFill>
                         </a:rPr>
                         <a:t>الدافعية</a:t>
@@ -4523,7 +4571,7 @@
                       <a:tailEnd type="none" w="med" len="med"/>
                     </a:lnB>
                     <a:solidFill>
-                      <a:srgbClr val="EAF2EC"/>
+                      <a:srgbClr val="EAF5EC"/>
                     </a:solidFill>
                   </a:tcPr>
                 </a:tc>
@@ -4662,7 +4710,7 @@
                       <a:r>
                         <a:rPr lang="ar-SA" altLang="en-US" sz="1500" b="1" dirty="0">
                           <a:solidFill>
-                            <a:srgbClr val="1F4D3A"/>
+                            <a:srgbClr val="00632B"/>
                           </a:solidFill>
                         </a:rPr>
                         <a:t>البراغماتية</a:t>
@@ -4771,7 +4819,7 @@
                       <a:tailEnd type="none" w="med" len="med"/>
                     </a:lnB>
                     <a:solidFill>
-                      <a:srgbClr val="EAF2EC"/>
+                      <a:srgbClr val="EAF5EC"/>
                     </a:solidFill>
                   </a:tcPr>
                 </a:tc>
@@ -4832,7 +4880,7 @@
                       <a:tailEnd type="none" w="med" len="med"/>
                     </a:lnB>
                     <a:solidFill>
-                      <a:srgbClr val="EAF2EC"/>
+                      <a:srgbClr val="EAF5EC"/>
                     </a:solidFill>
                   </a:tcPr>
                 </a:tc>
@@ -4847,7 +4895,7 @@
                       <a:r>
                         <a:rPr lang="ar-SA" altLang="en-US" sz="1500" b="1" dirty="0">
                           <a:solidFill>
-                            <a:srgbClr val="1F4D3A"/>
+                            <a:srgbClr val="00632B"/>
                           </a:solidFill>
                         </a:rPr>
                         <a:t>ضغط المسؤوليات</a:t>
@@ -4893,7 +4941,7 @@
                       <a:tailEnd type="none" w="med" len="med"/>
                     </a:lnB>
                     <a:solidFill>
-                      <a:srgbClr val="EAF2EC"/>
+                      <a:srgbClr val="EAF5EC"/>
                     </a:solidFill>
                   </a:tcPr>
                 </a:tc>
@@ -5032,7 +5080,7 @@
                       <a:r>
                         <a:rPr lang="ar-SA" altLang="en-US" sz="1500" b="1" dirty="0">
                           <a:solidFill>
-                            <a:srgbClr val="1F4D3A"/>
+                            <a:srgbClr val="00632B"/>
                           </a:solidFill>
                         </a:rPr>
                         <a:t>الذاكرة العاملة</a:t>
@@ -5162,13 +5210,13 @@
           <p:cNvPr id="2" name="Text 0"/>
           <p:cNvSpPr/>
           <p:nvPr>
-            <p:ph idx="100" type="title" hasCustomPrompt="1"/>
+            <p:ph idx="101" type="title" hasCustomPrompt="1"/>
           </p:nvPr>
         </p:nvSpPr>
         <p:spPr>
           <a:xfrm>
-            <a:off x="548640" y="365760"/>
-            <a:ext cx="11094415" cy="822960"/>
+            <a:off x="1645920" y="365760"/>
+            <a:ext cx="9997135" cy="822960"/>
           </a:xfrm>
           <a:prstGeom prst="rect">
             <a:avLst/>
@@ -5866,13 +5914,13 @@
           <p:cNvPr id="2" name="Text 0"/>
           <p:cNvSpPr/>
           <p:nvPr>
-            <p:ph idx="100" type="title" hasCustomPrompt="1"/>
+            <p:ph idx="101" type="title" hasCustomPrompt="1"/>
           </p:nvPr>
         </p:nvSpPr>
         <p:spPr>
           <a:xfrm>
-            <a:off x="548640" y="365760"/>
-            <a:ext cx="11094415" cy="822960"/>
+            <a:off x="1645920" y="365760"/>
+            <a:ext cx="9997135" cy="822960"/>
           </a:xfrm>
           <a:prstGeom prst="rect">
             <a:avLst/>
@@ -6570,13 +6618,13 @@
           <p:cNvPr id="2" name="Text 0"/>
           <p:cNvSpPr/>
           <p:nvPr>
-            <p:ph idx="100" type="title" hasCustomPrompt="1"/>
+            <p:ph idx="101" type="title" hasCustomPrompt="1"/>
           </p:nvPr>
         </p:nvSpPr>
         <p:spPr>
           <a:xfrm>
-            <a:off x="548640" y="365760"/>
-            <a:ext cx="11094415" cy="822960"/>
+            <a:off x="1645920" y="365760"/>
+            <a:ext cx="9997135" cy="822960"/>
           </a:xfrm>
           <a:prstGeom prst="rect">
             <a:avLst/>
@@ -7230,7 +7278,7 @@
           <p:cNvPr id="2" name="Text 0"/>
           <p:cNvSpPr/>
           <p:nvPr>
-            <p:ph idx="100" type="title" hasCustomPrompt="1"/>
+            <p:ph idx="101" type="title" hasCustomPrompt="1"/>
           </p:nvPr>
         </p:nvSpPr>
         <p:spPr>
@@ -7268,7 +7316,7 @@
           <p:cNvPr id="3" name="Text 0"/>
           <p:cNvSpPr/>
           <p:nvPr>
-            <p:ph idx="101" type="body" hasCustomPrompt="1"/>
+            <p:ph idx="102" type="body" hasCustomPrompt="1"/>
           </p:nvPr>
         </p:nvSpPr>
         <p:spPr>
@@ -7292,7 +7340,7 @@
             <a:r>
               <a:rPr lang="ar-SA" altLang="en-US" sz="2200" dirty="0">
                 <a:solidFill>
-                  <a:schemeClr val="accent2"/>
+                  <a:schemeClr val="bg2"/>
                 </a:solidFill>
               </a:rPr>
               <a:t>احترم خبرته  •  أشركه  •  اربطه بالواقع  •  ركّز المحتوى</a:t>
@@ -7301,33 +7349,9 @@
           </a:p>
         </p:txBody>
       </p:sp>
-      <p:pic>
-        <p:nvPicPr>
-          <p:cNvPr id="4" name="closing-icon" descr="مخيم">    </p:cNvPr>
-          <p:cNvPicPr>
-            <a:picLocks noChangeAspect="1"/>
-          </p:cNvPicPr>
-          <p:nvPr/>
-        </p:nvPicPr>
-        <p:blipFill>
-          <a:blip r:embed="rId1"/>
-          <a:stretch>
-            <a:fillRect/>
-          </a:stretch>
-        </p:blipFill>
-        <p:spPr>
-          <a:xfrm>
-            <a:off x="548640" y="548640"/>
-            <a:ext cx="1188720" cy="1188720"/>
-          </a:xfrm>
-          <a:prstGeom prst="rect">
-            <a:avLst/>
-          </a:prstGeom>
-        </p:spPr>
-      </p:pic>
-      <p:sp>
-        <p:nvSpPr>
-          <p:cNvPr id="5" name="Text 2"/>
+      <p:sp>
+        <p:nvSpPr>
+          <p:cNvPr id="4" name="Text 2"/>
           <p:cNvSpPr txBox="1"/>
           <p:nvPr/>
         </p:nvSpPr>
@@ -7380,31 +7404,31 @@
         <a:srgbClr val="FFFFFF"/>
       </a:lt1>
       <a:dk2>
-        <a:srgbClr val="1F4D3A"/>
+        <a:srgbClr val="00632B"/>
       </a:dk2>
       <a:lt2>
-        <a:srgbClr val="EAF2EC"/>
+        <a:srgbClr val="EAF5EC"/>
       </a:lt2>
       <a:accent1>
-        <a:srgbClr val="1F4D3A"/>
+        <a:srgbClr val="00632B"/>
       </a:accent1>
       <a:accent2>
-        <a:srgbClr val="D9A425"/>
+        <a:srgbClr val="D7141A"/>
       </a:accent2>
       <a:accent3>
-        <a:srgbClr val="2E6B50"/>
+        <a:srgbClr val="1E8A3E"/>
       </a:accent3>
       <a:accent4>
-        <a:srgbClr val="B23A3A"/>
+        <a:srgbClr val="B0101A"/>
       </a:accent4>
       <a:accent5>
         <a:srgbClr val="5E6E66"/>
       </a:accent5>
       <a:accent6>
-        <a:srgbClr val="8FB59E"/>
+        <a:srgbClr val="7FBF8E"/>
       </a:accent6>
       <a:hlink>
-        <a:srgbClr val="2E6B50"/>
+        <a:srgbClr val="1E8A3E"/>
       </a:hlink>
       <a:folHlink>
         <a:srgbClr val="5E6E66"/>

</xml_diff>